<commit_message>
fix(figure-pipeline): minor change in fig1, fig5 and fig6 to avoid copyright issues
</commit_message>
<xml_diff>
--- a/figure_pipeline/fig1_feats_data/assemble_fig1/assemble_fig1.pptx
+++ b/figure_pipeline/fig1_feats_data/assemble_fig1/assemble_fig1.pptx
@@ -243,7 +243,7 @@
           <a:p>
             <a:fld id="{3C3A1913-85D1-4C4E-AA02-085C6FE2A8B8}" type="datetimeFigureOut">
               <a:rPr lang="en-US" smtClean="0"/>
-              <a:t>4/17/2026</a:t>
+              <a:t>9/1/2026</a:t>
             </a:fld>
             <a:endParaRPr lang="en-US"/>
           </a:p>
@@ -413,7 +413,7 @@
           <a:p>
             <a:fld id="{3C3A1913-85D1-4C4E-AA02-085C6FE2A8B8}" type="datetimeFigureOut">
               <a:rPr lang="en-US" smtClean="0"/>
-              <a:t>4/17/2026</a:t>
+              <a:t>9/1/2026</a:t>
             </a:fld>
             <a:endParaRPr lang="en-US"/>
           </a:p>
@@ -593,7 +593,7 @@
           <a:p>
             <a:fld id="{3C3A1913-85D1-4C4E-AA02-085C6FE2A8B8}" type="datetimeFigureOut">
               <a:rPr lang="en-US" smtClean="0"/>
-              <a:t>4/17/2026</a:t>
+              <a:t>9/1/2026</a:t>
             </a:fld>
             <a:endParaRPr lang="en-US"/>
           </a:p>
@@ -763,7 +763,7 @@
           <a:p>
             <a:fld id="{3C3A1913-85D1-4C4E-AA02-085C6FE2A8B8}" type="datetimeFigureOut">
               <a:rPr lang="en-US" smtClean="0"/>
-              <a:t>4/17/2026</a:t>
+              <a:t>9/1/2026</a:t>
             </a:fld>
             <a:endParaRPr lang="en-US"/>
           </a:p>
@@ -1007,7 +1007,7 @@
           <a:p>
             <a:fld id="{3C3A1913-85D1-4C4E-AA02-085C6FE2A8B8}" type="datetimeFigureOut">
               <a:rPr lang="en-US" smtClean="0"/>
-              <a:t>4/17/2026</a:t>
+              <a:t>9/1/2026</a:t>
             </a:fld>
             <a:endParaRPr lang="en-US"/>
           </a:p>
@@ -1239,7 +1239,7 @@
           <a:p>
             <a:fld id="{3C3A1913-85D1-4C4E-AA02-085C6FE2A8B8}" type="datetimeFigureOut">
               <a:rPr lang="en-US" smtClean="0"/>
-              <a:t>4/17/2026</a:t>
+              <a:t>9/1/2026</a:t>
             </a:fld>
             <a:endParaRPr lang="en-US"/>
           </a:p>
@@ -1606,7 +1606,7 @@
           <a:p>
             <a:fld id="{3C3A1913-85D1-4C4E-AA02-085C6FE2A8B8}" type="datetimeFigureOut">
               <a:rPr lang="en-US" smtClean="0"/>
-              <a:t>4/17/2026</a:t>
+              <a:t>9/1/2026</a:t>
             </a:fld>
             <a:endParaRPr lang="en-US"/>
           </a:p>
@@ -1724,7 +1724,7 @@
           <a:p>
             <a:fld id="{3C3A1913-85D1-4C4E-AA02-085C6FE2A8B8}" type="datetimeFigureOut">
               <a:rPr lang="en-US" smtClean="0"/>
-              <a:t>4/17/2026</a:t>
+              <a:t>9/1/2026</a:t>
             </a:fld>
             <a:endParaRPr lang="en-US"/>
           </a:p>
@@ -1819,7 +1819,7 @@
           <a:p>
             <a:fld id="{3C3A1913-85D1-4C4E-AA02-085C6FE2A8B8}" type="datetimeFigureOut">
               <a:rPr lang="en-US" smtClean="0"/>
-              <a:t>4/17/2026</a:t>
+              <a:t>9/1/2026</a:t>
             </a:fld>
             <a:endParaRPr lang="en-US"/>
           </a:p>
@@ -2096,7 +2096,7 @@
           <a:p>
             <a:fld id="{3C3A1913-85D1-4C4E-AA02-085C6FE2A8B8}" type="datetimeFigureOut">
               <a:rPr lang="en-US" smtClean="0"/>
-              <a:t>4/17/2026</a:t>
+              <a:t>9/1/2026</a:t>
             </a:fld>
             <a:endParaRPr lang="en-US"/>
           </a:p>
@@ -2353,7 +2353,7 @@
           <a:p>
             <a:fld id="{3C3A1913-85D1-4C4E-AA02-085C6FE2A8B8}" type="datetimeFigureOut">
               <a:rPr lang="en-US" smtClean="0"/>
-              <a:t>4/17/2026</a:t>
+              <a:t>9/1/2026</a:t>
             </a:fld>
             <a:endParaRPr lang="en-US"/>
           </a:p>
@@ -2566,7 +2566,7 @@
           <a:p>
             <a:fld id="{3C3A1913-85D1-4C4E-AA02-085C6FE2A8B8}" type="datetimeFigureOut">
               <a:rPr lang="en-US" smtClean="0"/>
-              <a:t>4/17/2026</a:t>
+              <a:t>9/1/2026</a:t>
             </a:fld>
             <a:endParaRPr lang="en-US"/>
           </a:p>
@@ -3010,10 +3010,10 @@
       </p:pic>
       <p:pic>
         <p:nvPicPr>
-          <p:cNvPr id="3" name="Picture 2">
+          <p:cNvPr id="5" name="Picture 4">
             <a:extLst>
               <a:ext uri="{FF2B5EF4-FFF2-40B4-BE49-F238E27FC236}">
-                <a16:creationId xmlns:a16="http://schemas.microsoft.com/office/drawing/2014/main" id="{3DA46CCC-C79F-A534-645C-2D407E7C08BA}"/>
+                <a16:creationId xmlns:a16="http://schemas.microsoft.com/office/drawing/2014/main" id="{41CE8426-B325-E40E-A5AF-2EDCF40620AF}"/>
               </a:ext>
             </a:extLst>
           </p:cNvPr>
@@ -3030,15 +3030,15 @@
               </a:ext>
             </a:extLst>
           </a:blip>
-          <a:srcRect l="2801" t="2895" b="60269"/>
+          <a:srcRect l="2246" r="49273" b="25961"/>
           <a:stretch>
             <a:fillRect/>
           </a:stretch>
         </p:blipFill>
         <p:spPr>
           <a:xfrm>
-            <a:off x="7402" y="-1"/>
-            <a:ext cx="9136598" cy="1947744"/>
+            <a:off x="7402" y="1902478"/>
+            <a:ext cx="4525701" cy="3887801"/>
           </a:xfrm>
           <a:prstGeom prst="rect">
             <a:avLst/>
@@ -3047,10 +3047,10 @@
       </p:pic>
       <p:pic>
         <p:nvPicPr>
-          <p:cNvPr id="5" name="Picture 4">
+          <p:cNvPr id="3" name="Picture 2">
             <a:extLst>
               <a:ext uri="{FF2B5EF4-FFF2-40B4-BE49-F238E27FC236}">
-                <a16:creationId xmlns:a16="http://schemas.microsoft.com/office/drawing/2014/main" id="{41CE8426-B325-E40E-A5AF-2EDCF40620AF}"/>
+                <a16:creationId xmlns:a16="http://schemas.microsoft.com/office/drawing/2014/main" id="{81CF8591-9288-255E-191D-03BB8CB35CDA}"/>
               </a:ext>
             </a:extLst>
           </p:cNvPr>
@@ -3067,15 +3067,15 @@
               </a:ext>
             </a:extLst>
           </a:blip>
-          <a:srcRect l="2246" r="49273" b="25961"/>
+          <a:srcRect l="2100" b="66355"/>
           <a:stretch>
             <a:fillRect/>
           </a:stretch>
         </p:blipFill>
         <p:spPr>
           <a:xfrm>
-            <a:off x="7402" y="1902478"/>
-            <a:ext cx="4525701" cy="3887801"/>
+            <a:off x="7402" y="0"/>
+            <a:ext cx="9136598" cy="1766258"/>
           </a:xfrm>
           <a:prstGeom prst="rect">
             <a:avLst/>

</xml_diff>